<commit_message>
just like 10 years ago
</commit_message>
<xml_diff>
--- a/img/headers/Presentation_During_Meeting [Auto-saved].pptx
+++ b/img/headers/Presentation_During_Meeting [Auto-saved].pptx
@@ -2011,7 +2011,7 @@
           <a:p>
             <a:fld id="{A5C25525-F7D1-5B4F-9342-E93CEDD79A5C}" type="datetimeFigureOut">
               <a:rPr lang="en-GB" smtClean="0"/>
-              <a:t>04/02/2023</a:t>
+              <a:t>12/02/2023</a:t>
             </a:fld>
             <a:endParaRPr lang="en-GB"/>
           </a:p>
@@ -2509,7 +2509,7 @@
           <a:p>
             <a:fld id="{AE31A6DE-3705-5747-AEBF-BD3705E1DA93}" type="datetimeFigureOut">
               <a:rPr lang="en-GB" smtClean="0"/>
-              <a:t>04/02/2023</a:t>
+              <a:t>12/02/2023</a:t>
             </a:fld>
             <a:endParaRPr lang="en-GB" dirty="0"/>
           </a:p>
@@ -2707,7 +2707,7 @@
           <a:p>
             <a:fld id="{AE31A6DE-3705-5747-AEBF-BD3705E1DA93}" type="datetimeFigureOut">
               <a:rPr lang="en-GB" smtClean="0"/>
-              <a:t>04/02/2023</a:t>
+              <a:t>12/02/2023</a:t>
             </a:fld>
             <a:endParaRPr lang="en-GB" dirty="0"/>
           </a:p>
@@ -2915,7 +2915,7 @@
           <a:p>
             <a:fld id="{AE31A6DE-3705-5747-AEBF-BD3705E1DA93}" type="datetimeFigureOut">
               <a:rPr lang="en-GB" smtClean="0"/>
-              <a:t>04/02/2023</a:t>
+              <a:t>12/02/2023</a:t>
             </a:fld>
             <a:endParaRPr lang="en-GB" dirty="0"/>
           </a:p>
@@ -3113,7 +3113,7 @@
           <a:p>
             <a:fld id="{AE31A6DE-3705-5747-AEBF-BD3705E1DA93}" type="datetimeFigureOut">
               <a:rPr lang="en-GB" smtClean="0"/>
-              <a:t>04/02/2023</a:t>
+              <a:t>12/02/2023</a:t>
             </a:fld>
             <a:endParaRPr lang="en-GB" dirty="0"/>
           </a:p>
@@ -3388,7 +3388,7 @@
           <a:p>
             <a:fld id="{AE31A6DE-3705-5747-AEBF-BD3705E1DA93}" type="datetimeFigureOut">
               <a:rPr lang="en-GB" smtClean="0"/>
-              <a:t>04/02/2023</a:t>
+              <a:t>12/02/2023</a:t>
             </a:fld>
             <a:endParaRPr lang="en-GB" dirty="0"/>
           </a:p>
@@ -3653,7 +3653,7 @@
           <a:p>
             <a:fld id="{AE31A6DE-3705-5747-AEBF-BD3705E1DA93}" type="datetimeFigureOut">
               <a:rPr lang="en-GB" smtClean="0"/>
-              <a:t>04/02/2023</a:t>
+              <a:t>12/02/2023</a:t>
             </a:fld>
             <a:endParaRPr lang="en-GB" dirty="0"/>
           </a:p>
@@ -4065,7 +4065,7 @@
           <a:p>
             <a:fld id="{AE31A6DE-3705-5747-AEBF-BD3705E1DA93}" type="datetimeFigureOut">
               <a:rPr lang="en-GB" smtClean="0"/>
-              <a:t>04/02/2023</a:t>
+              <a:t>12/02/2023</a:t>
             </a:fld>
             <a:endParaRPr lang="en-GB" dirty="0"/>
           </a:p>
@@ -4206,7 +4206,7 @@
           <a:p>
             <a:fld id="{AE31A6DE-3705-5747-AEBF-BD3705E1DA93}" type="datetimeFigureOut">
               <a:rPr lang="en-GB" smtClean="0"/>
-              <a:t>04/02/2023</a:t>
+              <a:t>12/02/2023</a:t>
             </a:fld>
             <a:endParaRPr lang="en-GB" dirty="0"/>
           </a:p>
@@ -4319,7 +4319,7 @@
           <a:p>
             <a:fld id="{AE31A6DE-3705-5747-AEBF-BD3705E1DA93}" type="datetimeFigureOut">
               <a:rPr lang="en-GB" smtClean="0"/>
-              <a:t>04/02/2023</a:t>
+              <a:t>12/02/2023</a:t>
             </a:fld>
             <a:endParaRPr lang="en-GB" dirty="0"/>
           </a:p>
@@ -4630,7 +4630,7 @@
           <a:p>
             <a:fld id="{AE31A6DE-3705-5747-AEBF-BD3705E1DA93}" type="datetimeFigureOut">
               <a:rPr lang="en-GB" smtClean="0"/>
-              <a:t>04/02/2023</a:t>
+              <a:t>12/02/2023</a:t>
             </a:fld>
             <a:endParaRPr lang="en-GB" dirty="0"/>
           </a:p>
@@ -4918,7 +4918,7 @@
           <a:p>
             <a:fld id="{AE31A6DE-3705-5747-AEBF-BD3705E1DA93}" type="datetimeFigureOut">
               <a:rPr lang="en-GB" smtClean="0"/>
-              <a:t>04/02/2023</a:t>
+              <a:t>12/02/2023</a:t>
             </a:fld>
             <a:endParaRPr lang="en-GB" dirty="0"/>
           </a:p>
@@ -5159,7 +5159,7 @@
           <a:p>
             <a:fld id="{AE31A6DE-3705-5747-AEBF-BD3705E1DA93}" type="datetimeFigureOut">
               <a:rPr lang="en-GB" smtClean="0"/>
-              <a:t>04/02/2023</a:t>
+              <a:t>12/02/2023</a:t>
             </a:fld>
             <a:endParaRPr lang="en-GB" dirty="0"/>
           </a:p>
@@ -11241,7 +11241,7 @@
         </p:blipFill>
         <p:spPr>
           <a:xfrm>
-            <a:off x="2889158" y="1509512"/>
+            <a:off x="3151910" y="1509512"/>
             <a:ext cx="8136913" cy="5348488"/>
           </a:xfrm>
           <a:prstGeom prst="rect">
@@ -11733,7 +11733,7 @@
         </p:blipFill>
         <p:spPr>
           <a:xfrm>
-            <a:off x="0" y="1498004"/>
+            <a:off x="296237" y="1498004"/>
             <a:ext cx="11895763" cy="3861992"/>
           </a:xfrm>
           <a:prstGeom prst="rect">

</xml_diff>